<commit_message>
docs: clean up demo readme and polish presentation and video notes
</commit_message>
<xml_diff>
--- a/Taskboard_Presentation.pptx
+++ b/Taskboard_Presentation.pptx
@@ -3712,7 +3712,7 @@
               </a:defRPr>
             </a:pPr>
             <a:r>
-              <a:t>Deliverables &amp; Evaluation Status</a:t>
+              <a:t>Project Summary</a:t>
             </a:r>
           </a:p>
           <a:p>
@@ -3724,15 +3724,15 @@
               </a:defRPr>
             </a:pPr>
             <a:r>
-              <a:t>• 100/100 Evaluation Rubric Complete across Modules M1 through M10</a:t>
+              <a:t>• Complete end-to-end implementation covering all modules from M1 to M10</a:t>
             </a:r>
             <a:br/>
             <a:r>
-              <a:t>• Full Automation: Git Push → Pytest (9/9) → Vite Build → Trivy Security Gate → GHCR → Kubernetes &amp; Helm Deploy</a:t>
+              <a:t>• CI/CD pipeline runs automated Pytest tests, builds Vite frontend, performs Trivy vulnerability scans, and pushes images to GHCR</a:t>
             </a:r>
             <a:br/>
             <a:r>
-              <a:t>• Live Observability: Prometheus scrape endpoint (/metrics) &amp; Preconfigured Grafana Dashboard</a:t>
+              <a:t>• Deployed on Kubernetes using Helm with Ingress, HPA, and Prometheus metrics scraping</a:t>
             </a:r>
           </a:p>
         </p:txBody>
@@ -9647,7 +9647,7 @@
               </a:defRPr>
             </a:pPr>
             <a:r>
-              <a:t>MODULE M10 • DEMO &amp; FINAL SUBMISSION</a:t>
+              <a:t>MODULE M10 • DEMO &amp; SUBMISSION</a:t>
             </a:r>
           </a:p>
         </p:txBody>
@@ -9682,7 +9682,7 @@
               </a:defRPr>
             </a:pPr>
             <a:r>
-              <a:t>Walkthrough Video &amp; Verification Summary</a:t>
+              <a:t>Walkthrough &amp; Project Summary</a:t>
             </a:r>
           </a:p>
           <a:p>
@@ -9694,7 +9694,7 @@
               </a:defRPr>
             </a:pPr>
             <a:r>
-              <a:t>100/100 Evaluation Checklist, Recorded Execution, and GitHub Repository State</a:t>
+              <a:t>Overview of completed implementation and recorded execution across all modules</a:t>
             </a:r>
           </a:p>
         </p:txBody>

</xml_diff>